<commit_message>
Update portfolio: 2026-05-27 18:54:46
</commit_message>
<xml_diff>
--- a/Other Interesting Study Notebooks/ETL/Pipeline_Credito_Clase.pptx
+++ b/Other Interesting Study Notebooks/ETL/Pipeline_Credito_Clase.pptx
@@ -10937,40 +10937,6 @@
               <a:t>Evaluación</a:t>
             </a:r>
             <a:endParaRPr lang="en-US" sz="1100" dirty="0"/>
-          </a:p>
-        </p:txBody>
-      </p:sp>
-      <p:sp>
-        <p:nvSpPr>
-          <p:cNvPr id="51" name="Shape 49"/>
-          <p:cNvSpPr/>
-          <p:nvPr/>
-        </p:nvSpPr>
-        <p:spPr>
-          <a:xfrm>
-            <a:off x="4425697" y="2798064"/>
-            <a:ext cx="45719" cy="256032"/>
-          </a:xfrm>
-          <a:prstGeom prst="rect">
-            <a:avLst/>
-          </a:prstGeom>
-          <a:solidFill>
-            <a:srgbClr val="00D4FF">
-              <a:alpha val="80000"/>
-            </a:srgbClr>
-          </a:solidFill>
-          <a:ln w="12700">
-            <a:solidFill>
-              <a:srgbClr val="00D4FF"/>
-            </a:solidFill>
-            <a:prstDash val="solid"/>
-          </a:ln>
-        </p:spPr>
-        <p:txBody>
-          <a:bodyPr/>
-          <a:lstStyle/>
-          <a:p>
-            <a:endParaRPr lang="es-MX"/>
           </a:p>
         </p:txBody>
       </p:sp>

</xml_diff>